<commit_message>
Enkele teacher notes in pptx toegevoegd
</commit_message>
<xml_diff>
--- a/slides/S2_LoopsVectors.pptx
+++ b/slides/S2_LoopsVectors.pptx
@@ -139,6 +139,83 @@
 </p:presentation>
 </file>
 
+<file path=ppt/ink/ink1.xml><?xml version="1.0" encoding="utf-8"?>
+<inkml:ink xmlns:inkml="http://www.w3.org/2003/InkML">
+  <inkml:definitions>
+    <inkml:context xml:id="ctx0">
+      <inkml:inkSource xml:id="inkSrc0">
+        <inkml:traceFormat>
+          <inkml:channel name="X" type="integer" max="32767" units="cm"/>
+          <inkml:channel name="Y" type="integer" max="32767" units="cm"/>
+          <inkml:channel name="F" type="integer" max="1024" units="cm"/>
+          <inkml:channel name="T" type="integer" max="2.14748E9" units="dev"/>
+        </inkml:traceFormat>
+        <inkml:channelProperties>
+          <inkml:channelProperty channel="X" name="resolution" value="326.03979" units="1/cm"/>
+          <inkml:channelProperty channel="Y" name="resolution" value="573.04999" units="1/cm"/>
+          <inkml:channelProperty channel="F" name="resolution" value="0" units="1/cm"/>
+          <inkml:channelProperty channel="T" name="resolution" value="1" units="1/dev"/>
+        </inkml:channelProperties>
+      </inkml:inkSource>
+      <inkml:timestamp xml:id="ts0" timeString="2026-09-08T07:06:13.224"/>
+    </inkml:context>
+    <inkml:brush xml:id="br0">
+      <inkml:brushProperty name="width" value="0.05292" units="cm"/>
+      <inkml:brushProperty name="height" value="0.05292" units="cm"/>
+      <inkml:brushProperty name="color" value="#FF0000"/>
+    </inkml:brush>
+    <inkml:context xml:id="ctx1">
+      <inkml:inkSource xml:id="inkSrc1">
+        <inkml:traceFormat>
+          <inkml:channel name="X" type="integer" max="32767" units="cm"/>
+          <inkml:channel name="Y" type="integer" max="32767" units="cm"/>
+          <inkml:channel name="T" type="integer" max="2.14748E9" units="dev"/>
+        </inkml:traceFormat>
+        <inkml:channelProperties>
+          <inkml:channelProperty channel="X" name="resolution" value="326.03979" units="1/cm"/>
+          <inkml:channelProperty channel="Y" name="resolution" value="573.04999" units="1/cm"/>
+          <inkml:channelProperty channel="T" name="resolution" value="1" units="1/dev"/>
+        </inkml:channelProperties>
+      </inkml:inkSource>
+      <inkml:timestamp xml:id="ts1" timeString="2026-09-08T07:06:13.587"/>
+    </inkml:context>
+  </inkml:definitions>
+  <inkml:trace contextRef="#ctx0" brushRef="#br0">2577 8701 1312 0,'0'0'0'0,"0"0"0"0,0 0 0 15,0 0 0-15</inkml:trace>
+  <inkml:trace contextRef="#ctx1" brushRef="#br0">2426 9015 0,'-114'19'0,"-70"13"15,184-32-15,-207 44 0,-12 9 0,219-53 16</inkml:trace>
+</inkml:ink>
+</file>
+
+<file path=ppt/ink/ink2.xml><?xml version="1.0" encoding="utf-8"?>
+<inkml:ink xmlns:inkml="http://www.w3.org/2003/InkML">
+  <inkml:definitions>
+    <inkml:context xml:id="ctx0">
+      <inkml:inkSource xml:id="inkSrc0">
+        <inkml:traceFormat>
+          <inkml:channel name="X" type="integer" max="32767" units="cm"/>
+          <inkml:channel name="Y" type="integer" max="32767" units="cm"/>
+          <inkml:channel name="F" type="integer" max="1024" units="cm"/>
+          <inkml:channel name="T" type="integer" max="2.14748E9" units="dev"/>
+        </inkml:traceFormat>
+        <inkml:channelProperties>
+          <inkml:channelProperty channel="X" name="resolution" value="326.03979" units="1/cm"/>
+          <inkml:channelProperty channel="Y" name="resolution" value="573.04999" units="1/cm"/>
+          <inkml:channelProperty channel="F" name="resolution" value="0" units="1/cm"/>
+          <inkml:channelProperty channel="T" name="resolution" value="1" units="1/dev"/>
+        </inkml:channelProperties>
+      </inkml:inkSource>
+      <inkml:timestamp xml:id="ts0" timeString="2026-09-08T07:35:57.051"/>
+    </inkml:context>
+    <inkml:brush xml:id="br0">
+      <inkml:brushProperty name="width" value="0.05292" units="cm"/>
+      <inkml:brushProperty name="height" value="0.05292" units="cm"/>
+      <inkml:brushProperty name="color" value="#FF0000"/>
+    </inkml:brush>
+  </inkml:definitions>
+  <inkml:trace contextRef="#ctx0" brushRef="#br0">14256 10381 1312 0,'-100'8'0'0,"-5"2"0"15,8 0 0-15,8 3 0 16,8-2 0-16,2 0 0 15,8 1 0 1,17-3 0-16</inkml:trace>
+  <inkml:trace contextRef="#ctx0" brushRef="#br0" timeOffset="4998.56">10255 11234 1312 0,'0'27'0'15</inkml:trace>
+</inkml:ink>
+</file>
+
 <file path=ppt/notesMasters/notesMaster1.xml><?xml version="1.0" encoding="utf-8"?>
 <p:notesMaster xmlns:a="http://schemas.openxmlformats.org/drawingml/2006/main" xmlns:r="http://schemas.openxmlformats.org/officeDocument/2006/relationships" xmlns:p="http://schemas.openxmlformats.org/presentationml/2006/main">
   <p:cSld>
@@ -221,7 +298,7 @@
           <a:p>
             <a:fld id="{0D2E6FBB-00AE-448E-9154-F7263C52CE6B}" type="datetimeFigureOut">
               <a:rPr lang="en-NL" smtClean="0"/>
-              <a:t>13/02/2026</a:t>
+              <a:t>09/08/2026</a:t>
             </a:fld>
             <a:endParaRPr lang="en-NL"/>
           </a:p>
@@ -380,7 +457,7 @@
           <a:p>
             <a:fld id="{893F63FC-705A-44E0-B501-047B8E01A1D2}" type="slidenum">
               <a:rPr lang="en-NL" smtClean="0"/>
-              <a:t>‹#›</a:t>
+              <a:t>‹nr.›</a:t>
             </a:fld>
             <a:endParaRPr lang="en-NL"/>
           </a:p>
@@ -508,6 +585,120 @@
       </p:grpSpPr>
       <p:sp>
         <p:nvSpPr>
+          <p:cNvPr id="2" name="Tijdelijke aanduiding voor dia-afbeelding 1"/>
+          <p:cNvSpPr>
+            <a:spLocks noGrp="1" noRot="1" noChangeAspect="1"/>
+          </p:cNvSpPr>
+          <p:nvPr>
+            <p:ph type="sldImg"/>
+          </p:nvPr>
+        </p:nvSpPr>
+        <p:spPr/>
+      </p:sp>
+      <p:sp>
+        <p:nvSpPr>
+          <p:cNvPr id="3" name="Tijdelijke aanduiding voor notities 2"/>
+          <p:cNvSpPr>
+            <a:spLocks noGrp="1"/>
+          </p:cNvSpPr>
+          <p:nvPr>
+            <p:ph type="body" idx="1"/>
+          </p:nvPr>
+        </p:nvSpPr>
+        <p:spPr/>
+        <p:txBody>
+          <a:bodyPr/>
+          <a:lstStyle/>
+          <a:p>
+            <a:r>
+              <a:rPr lang="nl-NL"/>
+              <a:t>int a[] = {0,1,2,3}</a:t>
+            </a:r>
+          </a:p>
+          <a:p>
+            <a:r>
+              <a:rPr lang="nl-NL"/>
+              <a:t>for (int n: a) cout &lt;&lt; i &lt;&lt;endl;</a:t>
+            </a:r>
+          </a:p>
+          <a:p>
+            <a:r>
+              <a:rPr lang="nl-NL"/>
+              <a:t>for (auto i: a) cout &lt;&lt; i &lt;&lt; endl;</a:t>
+            </a:r>
+          </a:p>
+          <a:p>
+            <a:endParaRPr lang="nl-NL"/>
+          </a:p>
+          <a:p>
+            <a:r>
+              <a:rPr lang="nl-NL"/>
+              <a:t>int l = v.size(); // bv 10</a:t>
+            </a:r>
+          </a:p>
+          <a:p>
+            <a:r>
+              <a:rPr lang="nl-NL"/>
+              <a:t>for (int l; l: v) // klopt dit?</a:t>
+            </a:r>
+          </a:p>
+        </p:txBody>
+      </p:sp>
+      <p:sp>
+        <p:nvSpPr>
+          <p:cNvPr id="4" name="Tijdelijke aanduiding voor dianummer 3"/>
+          <p:cNvSpPr>
+            <a:spLocks noGrp="1"/>
+          </p:cNvSpPr>
+          <p:nvPr>
+            <p:ph type="sldNum" sz="quarter" idx="5"/>
+          </p:nvPr>
+        </p:nvSpPr>
+        <p:spPr/>
+        <p:txBody>
+          <a:bodyPr/>
+          <a:lstStyle/>
+          <a:p>
+            <a:fld id="{893F63FC-705A-44E0-B501-047B8E01A1D2}" type="slidenum">
+              <a:rPr lang="en-NL" smtClean="0"/>
+              <a:t>6</a:t>
+            </a:fld>
+            <a:endParaRPr lang="en-NL"/>
+          </a:p>
+        </p:txBody>
+      </p:sp>
+    </p:spTree>
+    <p:extLst>
+      <p:ext uri="{BB962C8B-B14F-4D97-AF65-F5344CB8AC3E}">
+        <p14:creationId xmlns:p14="http://schemas.microsoft.com/office/powerpoint/2010/main" val="163352240"/>
+      </p:ext>
+    </p:extLst>
+  </p:cSld>
+  <p:clrMapOvr>
+    <a:masterClrMapping/>
+  </p:clrMapOvr>
+</p:notes>
+</file>
+
+<file path=ppt/notesSlides/notesSlide2.xml><?xml version="1.0" encoding="utf-8"?>
+<p:notes xmlns:a="http://schemas.openxmlformats.org/drawingml/2006/main" xmlns:r="http://schemas.openxmlformats.org/officeDocument/2006/relationships" xmlns:p="http://schemas.openxmlformats.org/presentationml/2006/main">
+  <p:cSld>
+    <p:spTree>
+      <p:nvGrpSpPr>
+        <p:cNvPr id="1" name=""/>
+        <p:cNvGrpSpPr/>
+        <p:nvPr/>
+      </p:nvGrpSpPr>
+      <p:grpSpPr>
+        <a:xfrm>
+          <a:off x="0" y="0"/>
+          <a:ext cx="0" cy="0"/>
+          <a:chOff x="0" y="0"/>
+          <a:chExt cx="0" cy="0"/>
+        </a:xfrm>
+      </p:grpSpPr>
+      <p:sp>
+        <p:nvSpPr>
           <p:cNvPr id="2" name="Slide Image Placeholder 1"/>
           <p:cNvSpPr>
             <a:spLocks noGrp="1" noRot="1" noChangeAspect="1"/>
@@ -573,7 +764,7 @@
 </p:notes>
 </file>
 
-<file path=ppt/notesSlides/notesSlide2.xml><?xml version="1.0" encoding="utf-8"?>
+<file path=ppt/notesSlides/notesSlide3.xml><?xml version="1.0" encoding="utf-8"?>
 <p:notes xmlns:a="http://schemas.openxmlformats.org/drawingml/2006/main" xmlns:r="http://schemas.openxmlformats.org/officeDocument/2006/relationships" xmlns:p="http://schemas.openxmlformats.org/presentationml/2006/main">
   <p:cSld>
     <p:spTree>
@@ -812,7 +1003,7 @@
           <a:p>
             <a:fld id="{827B60F3-478F-4BAF-AD9C-CE6A110AA0AE}" type="datetimeFigureOut">
               <a:rPr lang="en-NL" smtClean="0"/>
-              <a:t>13/02/2026</a:t>
+              <a:t>09/08/2026</a:t>
             </a:fld>
             <a:endParaRPr lang="en-NL"/>
           </a:p>
@@ -854,7 +1045,7 @@
           <a:p>
             <a:fld id="{E04B92AD-8817-4790-B15E-A2478E2662E2}" type="slidenum">
               <a:rPr lang="en-NL" smtClean="0"/>
-              <a:t>‹#›</a:t>
+              <a:t>‹nr.›</a:t>
             </a:fld>
             <a:endParaRPr lang="en-NL"/>
           </a:p>
@@ -982,7 +1173,7 @@
           <a:p>
             <a:fld id="{827B60F3-478F-4BAF-AD9C-CE6A110AA0AE}" type="datetimeFigureOut">
               <a:rPr lang="en-NL" smtClean="0"/>
-              <a:t>13/02/2026</a:t>
+              <a:t>09/08/2026</a:t>
             </a:fld>
             <a:endParaRPr lang="en-NL"/>
           </a:p>
@@ -1024,7 +1215,7 @@
           <a:p>
             <a:fld id="{E04B92AD-8817-4790-B15E-A2478E2662E2}" type="slidenum">
               <a:rPr lang="en-NL" smtClean="0"/>
-              <a:t>‹#›</a:t>
+              <a:t>‹nr.›</a:t>
             </a:fld>
             <a:endParaRPr lang="en-NL"/>
           </a:p>
@@ -1162,7 +1353,7 @@
           <a:p>
             <a:fld id="{827B60F3-478F-4BAF-AD9C-CE6A110AA0AE}" type="datetimeFigureOut">
               <a:rPr lang="en-NL" smtClean="0"/>
-              <a:t>13/02/2026</a:t>
+              <a:t>09/08/2026</a:t>
             </a:fld>
             <a:endParaRPr lang="en-NL"/>
           </a:p>
@@ -1204,7 +1395,7 @@
           <a:p>
             <a:fld id="{E04B92AD-8817-4790-B15E-A2478E2662E2}" type="slidenum">
               <a:rPr lang="en-NL" smtClean="0"/>
-              <a:t>‹#›</a:t>
+              <a:t>‹nr.›</a:t>
             </a:fld>
             <a:endParaRPr lang="en-NL"/>
           </a:p>
@@ -1332,7 +1523,7 @@
           <a:p>
             <a:fld id="{827B60F3-478F-4BAF-AD9C-CE6A110AA0AE}" type="datetimeFigureOut">
               <a:rPr lang="en-NL" smtClean="0"/>
-              <a:t>13/02/2026</a:t>
+              <a:t>09/08/2026</a:t>
             </a:fld>
             <a:endParaRPr lang="en-NL"/>
           </a:p>
@@ -1374,7 +1565,7 @@
           <a:p>
             <a:fld id="{E04B92AD-8817-4790-B15E-A2478E2662E2}" type="slidenum">
               <a:rPr lang="en-NL" smtClean="0"/>
-              <a:t>‹#›</a:t>
+              <a:t>‹nr.›</a:t>
             </a:fld>
             <a:endParaRPr lang="en-NL"/>
           </a:p>
@@ -1578,7 +1769,7 @@
           <a:p>
             <a:fld id="{827B60F3-478F-4BAF-AD9C-CE6A110AA0AE}" type="datetimeFigureOut">
               <a:rPr lang="en-NL" smtClean="0"/>
-              <a:t>13/02/2026</a:t>
+              <a:t>09/08/2026</a:t>
             </a:fld>
             <a:endParaRPr lang="en-NL"/>
           </a:p>
@@ -1620,7 +1811,7 @@
           <a:p>
             <a:fld id="{E04B92AD-8817-4790-B15E-A2478E2662E2}" type="slidenum">
               <a:rPr lang="en-NL" smtClean="0"/>
-              <a:t>‹#›</a:t>
+              <a:t>‹nr.›</a:t>
             </a:fld>
             <a:endParaRPr lang="en-NL"/>
           </a:p>
@@ -1810,7 +2001,7 @@
           <a:p>
             <a:fld id="{827B60F3-478F-4BAF-AD9C-CE6A110AA0AE}" type="datetimeFigureOut">
               <a:rPr lang="en-NL" smtClean="0"/>
-              <a:t>13/02/2026</a:t>
+              <a:t>09/08/2026</a:t>
             </a:fld>
             <a:endParaRPr lang="en-NL"/>
           </a:p>
@@ -1852,7 +2043,7 @@
           <a:p>
             <a:fld id="{E04B92AD-8817-4790-B15E-A2478E2662E2}" type="slidenum">
               <a:rPr lang="en-NL" smtClean="0"/>
-              <a:t>‹#›</a:t>
+              <a:t>‹nr.›</a:t>
             </a:fld>
             <a:endParaRPr lang="en-NL"/>
           </a:p>
@@ -2177,7 +2368,7 @@
           <a:p>
             <a:fld id="{827B60F3-478F-4BAF-AD9C-CE6A110AA0AE}" type="datetimeFigureOut">
               <a:rPr lang="en-NL" smtClean="0"/>
-              <a:t>13/02/2026</a:t>
+              <a:t>09/08/2026</a:t>
             </a:fld>
             <a:endParaRPr lang="en-NL"/>
           </a:p>
@@ -2219,7 +2410,7 @@
           <a:p>
             <a:fld id="{E04B92AD-8817-4790-B15E-A2478E2662E2}" type="slidenum">
               <a:rPr lang="en-NL" smtClean="0"/>
-              <a:t>‹#›</a:t>
+              <a:t>‹nr.›</a:t>
             </a:fld>
             <a:endParaRPr lang="en-NL"/>
           </a:p>
@@ -2295,7 +2486,7 @@
           <a:p>
             <a:fld id="{827B60F3-478F-4BAF-AD9C-CE6A110AA0AE}" type="datetimeFigureOut">
               <a:rPr lang="en-NL" smtClean="0"/>
-              <a:t>13/02/2026</a:t>
+              <a:t>09/08/2026</a:t>
             </a:fld>
             <a:endParaRPr lang="en-NL"/>
           </a:p>
@@ -2337,7 +2528,7 @@
           <a:p>
             <a:fld id="{E04B92AD-8817-4790-B15E-A2478E2662E2}" type="slidenum">
               <a:rPr lang="en-NL" smtClean="0"/>
-              <a:t>‹#›</a:t>
+              <a:t>‹nr.›</a:t>
             </a:fld>
             <a:endParaRPr lang="en-NL"/>
           </a:p>
@@ -2390,7 +2581,7 @@
           <a:p>
             <a:fld id="{827B60F3-478F-4BAF-AD9C-CE6A110AA0AE}" type="datetimeFigureOut">
               <a:rPr lang="en-NL" smtClean="0"/>
-              <a:t>13/02/2026</a:t>
+              <a:t>09/08/2026</a:t>
             </a:fld>
             <a:endParaRPr lang="en-NL"/>
           </a:p>
@@ -2432,7 +2623,7 @@
           <a:p>
             <a:fld id="{E04B92AD-8817-4790-B15E-A2478E2662E2}" type="slidenum">
               <a:rPr lang="en-NL" smtClean="0"/>
-              <a:t>‹#›</a:t>
+              <a:t>‹nr.›</a:t>
             </a:fld>
             <a:endParaRPr lang="en-NL"/>
           </a:p>
@@ -2667,7 +2858,7 @@
           <a:p>
             <a:fld id="{827B60F3-478F-4BAF-AD9C-CE6A110AA0AE}" type="datetimeFigureOut">
               <a:rPr lang="en-NL" smtClean="0"/>
-              <a:t>13/02/2026</a:t>
+              <a:t>09/08/2026</a:t>
             </a:fld>
             <a:endParaRPr lang="en-NL"/>
           </a:p>
@@ -2709,7 +2900,7 @@
           <a:p>
             <a:fld id="{E04B92AD-8817-4790-B15E-A2478E2662E2}" type="slidenum">
               <a:rPr lang="en-NL" smtClean="0"/>
-              <a:t>‹#›</a:t>
+              <a:t>‹nr.›</a:t>
             </a:fld>
             <a:endParaRPr lang="en-NL"/>
           </a:p>
@@ -2924,7 +3115,7 @@
           <a:p>
             <a:fld id="{827B60F3-478F-4BAF-AD9C-CE6A110AA0AE}" type="datetimeFigureOut">
               <a:rPr lang="en-NL" smtClean="0"/>
-              <a:t>13/02/2026</a:t>
+              <a:t>09/08/2026</a:t>
             </a:fld>
             <a:endParaRPr lang="en-NL"/>
           </a:p>
@@ -2966,7 +3157,7 @@
           <a:p>
             <a:fld id="{E04B92AD-8817-4790-B15E-A2478E2662E2}" type="slidenum">
               <a:rPr lang="en-NL" smtClean="0"/>
-              <a:t>‹#›</a:t>
+              <a:t>‹nr.›</a:t>
             </a:fld>
             <a:endParaRPr lang="en-NL"/>
           </a:p>
@@ -3137,7 +3328,7 @@
           <a:p>
             <a:fld id="{827B60F3-478F-4BAF-AD9C-CE6A110AA0AE}" type="datetimeFigureOut">
               <a:rPr lang="en-NL" smtClean="0"/>
-              <a:t>13/02/2026</a:t>
+              <a:t>09/08/2026</a:t>
             </a:fld>
             <a:endParaRPr lang="en-NL"/>
           </a:p>
@@ -3215,7 +3406,7 @@
           <a:p>
             <a:fld id="{E04B92AD-8817-4790-B15E-A2478E2662E2}" type="slidenum">
               <a:rPr lang="en-NL" smtClean="0"/>
-              <a:t>‹#›</a:t>
+              <a:t>‹nr.›</a:t>
             </a:fld>
             <a:endParaRPr lang="en-NL"/>
           </a:p>
@@ -15095,6 +15286,57 @@
           </a:p>
         </p:txBody>
       </p:sp>
+      <mc:AlternateContent xmlns:mc="http://schemas.openxmlformats.org/markup-compatibility/2006">
+        <mc:Choice xmlns:p14="http://schemas.microsoft.com/office/powerpoint/2010/main" Requires="p14">
+          <p:contentPart p14:bwMode="auto" r:id="rId2">
+            <p14:nvContentPartPr>
+              <p14:cNvPr id="4" name="Inkt 3">
+                <a:extLst>
+                  <a:ext uri="{FF2B5EF4-FFF2-40B4-BE49-F238E27FC236}">
+                    <a16:creationId xmlns:a16="http://schemas.microsoft.com/office/drawing/2014/main" id="{F8D87728-3FEB-B88F-E519-A384EA52E717}"/>
+                  </a:ext>
+                </a:extLst>
+              </p14:cNvPr>
+              <p14:cNvContentPartPr/>
+              <p14:nvPr/>
+            </p14:nvContentPartPr>
+            <p14:xfrm>
+              <a:off x="3691800" y="3737160"/>
+              <a:ext cx="1440720" cy="317160"/>
+            </p14:xfrm>
+          </p:contentPart>
+        </mc:Choice>
+        <mc:Fallback>
+          <p:pic>
+            <p:nvPicPr>
+              <p:cNvPr id="4" name="Inkt 3">
+                <a:extLst>
+                  <a:ext uri="{FF2B5EF4-FFF2-40B4-BE49-F238E27FC236}">
+                    <a16:creationId xmlns:a16="http://schemas.microsoft.com/office/drawing/2014/main" id="{F8D87728-3FEB-B88F-E519-A384EA52E717}"/>
+                  </a:ext>
+                </a:extLst>
+              </p:cNvPr>
+              <p:cNvPicPr/>
+              <p:nvPr/>
+            </p:nvPicPr>
+            <p:blipFill>
+              <a:blip r:embed="rId3"/>
+              <a:stretch>
+                <a:fillRect/>
+              </a:stretch>
+            </p:blipFill>
+            <p:spPr>
+              <a:xfrm>
+                <a:off x="3682440" y="3727800"/>
+                <a:ext cx="1459440" cy="335880"/>
+              </a:xfrm>
+              <a:prstGeom prst="rect">
+                <a:avLst/>
+              </a:prstGeom>
+            </p:spPr>
+          </p:pic>
+        </mc:Fallback>
+      </mc:AlternateContent>
     </p:spTree>
     <p:extLst>
       <p:ext uri="{BB962C8B-B14F-4D97-AF65-F5344CB8AC3E}">
@@ -16203,6 +16445,57 @@
           </a:p>
         </p:txBody>
       </p:sp>
+      <mc:AlternateContent xmlns:mc="http://schemas.openxmlformats.org/markup-compatibility/2006">
+        <mc:Choice xmlns:p14="http://schemas.microsoft.com/office/powerpoint/2010/main" Requires="p14">
+          <p:contentPart p14:bwMode="auto" r:id="rId2">
+            <p14:nvContentPartPr>
+              <p14:cNvPr id="4" name="Inkt 3">
+                <a:extLst>
+                  <a:ext uri="{FF2B5EF4-FFF2-40B4-BE49-F238E27FC236}">
+                    <a16:creationId xmlns:a16="http://schemas.microsoft.com/office/drawing/2014/main" id="{912880B3-CC57-B26F-EAE6-7F7CC96566DE}"/>
+                  </a:ext>
+                </a:extLst>
+              </p14:cNvPr>
+              <p14:cNvContentPartPr/>
+              <p14:nvPr/>
+            </p14:nvContentPartPr>
+            <p14:xfrm>
+              <a:off x="612720" y="3132360"/>
+              <a:ext cx="315360" cy="166680"/>
+            </p14:xfrm>
+          </p:contentPart>
+        </mc:Choice>
+        <mc:Fallback>
+          <p:pic>
+            <p:nvPicPr>
+              <p:cNvPr id="4" name="Inkt 3">
+                <a:extLst>
+                  <a:ext uri="{FF2B5EF4-FFF2-40B4-BE49-F238E27FC236}">
+                    <a16:creationId xmlns:a16="http://schemas.microsoft.com/office/drawing/2014/main" id="{912880B3-CC57-B26F-EAE6-7F7CC96566DE}"/>
+                  </a:ext>
+                </a:extLst>
+              </p:cNvPr>
+              <p:cNvPicPr/>
+              <p:nvPr/>
+            </p:nvPicPr>
+            <p:blipFill>
+              <a:blip r:embed="rId3"/>
+              <a:stretch>
+                <a:fillRect/>
+              </a:stretch>
+            </p:blipFill>
+            <p:spPr>
+              <a:xfrm>
+                <a:off x="603360" y="3123000"/>
+                <a:ext cx="334080" cy="185400"/>
+              </a:xfrm>
+              <a:prstGeom prst="rect">
+                <a:avLst/>
+              </a:prstGeom>
+            </p:spPr>
+          </p:pic>
+        </mc:Fallback>
+      </mc:AlternateContent>
     </p:spTree>
     <p:extLst>
       <p:ext uri="{BB962C8B-B14F-4D97-AF65-F5344CB8AC3E}">

</xml_diff>